<commit_message>
Update greedy solver and main menu script with improved lower bound calculations and parallelized execution option for Program 1.
</commit_message>
<xml_diff>
--- a/docs/SCP_RA03.pptx
+++ b/docs/SCP_RA03.pptx
@@ -2049,7 +2049,7 @@
                 <a:ea typeface="Inter" pitchFamily="34" charset="-122"/>
                 <a:cs typeface="Inter" pitchFamily="34" charset="-120"/>
               </a:rPr>
-              <a:t>Solução ótima não garantida para p=13 e p=14 (NP-difícil)</a:t>
+              <a:t>Solução ótima global não garantida pelo greedy para nenhum p (NP-difícil)</a:t>
             </a:r>
             <a:endParaRPr lang="en-US" sz="1425" dirty="0"/>
           </a:p>
@@ -2904,7 +2904,7 @@
                 <a:ea typeface="Inter" pitchFamily="34" charset="-122"/>
                 <a:cs typeface="Inter" pitchFamily="34" charset="-120"/>
               </a:rPr>
-              <a:t>Paralelização: multiprocessing para count[] — speedup teórico </a:t>
+              <a:t>Paralelização já implementada no Programa 5 (p=11, speedup ~3× em 4 núcleos). Melhorias futuras: expandir paralelismo, portar gargalos para C/Cython</a:t>
             </a:r>
             <a:r>
               <a:rPr lang="en-US" sz="1425" b="1" dirty="0">
@@ -2915,7 +2915,7 @@
                 <a:ea typeface="Inter" pitchFamily="34" charset="-122"/>
                 <a:cs typeface="Inter" pitchFamily="34" charset="-120"/>
               </a:rPr>
-              <a:t>~8× em 8 núcleos </a:t>
+              <a:t/>
             </a:r>
             <a:r>
               <a:rPr lang="en-US" sz="1425" dirty="0">
@@ -2926,7 +2926,7 @@
                 <a:ea typeface="Inter" pitchFamily="34" charset="-122"/>
                 <a:cs typeface="Inter" pitchFamily="34" charset="-120"/>
               </a:rPr>
-              <a:t>(gargalo embaraçosamente paralelo)</a:t>
+              <a:t/>
             </a:r>
             <a:endParaRPr lang="en-US" sz="1425" dirty="0"/>
           </a:p>
@@ -4327,7 +4327,7 @@
                 <a:ea typeface="JetBrains Mono" pitchFamily="34" charset="-122"/>
                 <a:cs typeface="JetBrains Mono" pitchFamily="34" charset="-120"/>
               </a:rPr>
-              <a:t>Para cada </a:t>
+              <a:t>Para cada p ∈ {14,13,12,11}, encontrar</a:t>
             </a:r>
             <a:r>
               <a:rPr lang="en-US" sz="1500" dirty="0">
@@ -4338,7 +4338,7 @@
                 <a:ea typeface="JetBrains Mono" pitchFamily="34" charset="-122"/>
                 <a:cs typeface="JetBrains Mono" pitchFamily="34" charset="-120"/>
               </a:rPr>
-              <a:t>p ∈ {14,13,12,11}</a:t>
+              <a:t/>
             </a:r>
             <a:r>
               <a:rPr lang="en-US" sz="1500" dirty="0">
@@ -4349,7 +4349,7 @@
                 <a:ea typeface="JetBrains Mono" pitchFamily="34" charset="-122"/>
                 <a:cs typeface="JetBrains Mono" pitchFamily="34" charset="-120"/>
               </a:rPr>
-              <a:t>, encontrar</a:t>
+              <a:t/>
             </a:r>
             <a:endParaRPr lang="en-US" sz="1500" dirty="0"/>
           </a:p>
@@ -4393,7 +4393,7 @@
                 <a:ea typeface="JetBrains Mono" pitchFamily="34" charset="-122"/>
                 <a:cs typeface="JetBrains Mono" pitchFamily="34" charset="-120"/>
               </a:rPr>
-              <a:t>o </a:t>
+              <a:t>um SB ⊆ S15 tal que: (objetivo: minimizar |SB|; implementação: greedy aproximativo)</a:t>
             </a:r>
             <a:r>
               <a:rPr lang="en-US" sz="1500" b="1" dirty="0">
@@ -4404,7 +4404,7 @@
                 <a:ea typeface="JetBrains Mono" pitchFamily="34" charset="-122"/>
                 <a:cs typeface="JetBrains Mono" pitchFamily="34" charset="-120"/>
               </a:rPr>
-              <a:t>menor SB ⊆ S</a:t>
+              <a:t/>
             </a:r>
             <a:r>
               <a:rPr lang="en-US" sz="1250" b="1" baseline="-40000" dirty="0">
@@ -4415,7 +4415,7 @@
                 <a:ea typeface="JetBrains Mono" pitchFamily="34" charset="-122"/>
                 <a:cs typeface="JetBrains Mono" pitchFamily="34" charset="-120"/>
               </a:rPr>
-              <a:t>15 </a:t>
+              <a:t/>
             </a:r>
             <a:r>
               <a:rPr lang="en-US" sz="1500" dirty="0">
@@ -4426,7 +4426,7 @@
                 <a:ea typeface="JetBrains Mono" pitchFamily="34" charset="-122"/>
                 <a:cs typeface="JetBrains Mono" pitchFamily="34" charset="-120"/>
               </a:rPr>
-              <a:t>tal que:</a:t>
+              <a:t/>
             </a:r>
             <a:endParaRPr lang="en-US" sz="1500" dirty="0"/>
           </a:p>
@@ -8207,7 +8207,7 @@
                 <a:ea typeface="JetBrains Mono" pitchFamily="34" charset="-122"/>
                 <a:cs typeface="JetBrains Mono" pitchFamily="34" charset="-120"/>
               </a:rPr>
-              <a:t>~67 milhões</a:t>
+              <a:t>49.031.400</a:t>
             </a:r>
             <a:endParaRPr lang="en-US" sz="1650" dirty="0"/>
           </a:p>
@@ -8466,7 +8466,7 @@
                 <a:ea typeface="JetBrains Mono" pitchFamily="34" charset="-122"/>
                 <a:cs typeface="JetBrains Mono" pitchFamily="34" charset="-120"/>
               </a:rPr>
-              <a:t>~546 milhões</a:t>
+              <a:t>343.219.800</a:t>
             </a:r>
             <a:endParaRPr lang="en-US" sz="1650" dirty="0"/>
           </a:p>
@@ -8725,7 +8725,7 @@
                 <a:ea typeface="JetBrains Mono" pitchFamily="34" charset="-122"/>
                 <a:cs typeface="JetBrains Mono" pitchFamily="34" charset="-120"/>
               </a:rPr>
-              <a:t>~2,37 bilhões</a:t>
+              <a:t>1.487.285.800</a:t>
             </a:r>
             <a:endParaRPr lang="en-US" sz="1650" dirty="0"/>
           </a:p>
@@ -8957,7 +8957,7 @@
                 <a:ea typeface="JetBrains Mono" pitchFamily="34" charset="-122"/>
                 <a:cs typeface="JetBrains Mono" pitchFamily="34" charset="-120"/>
               </a:rPr>
-              <a:t>~6,08 bilhões</a:t>
+              <a:t>4.461.857.400</a:t>
             </a:r>
             <a:endParaRPr lang="en-US" sz="1650" dirty="0"/>
           </a:p>
@@ -17727,7 +17727,7 @@
                 <a:ea typeface="Inter" pitchFamily="34" charset="-122"/>
                 <a:cs typeface="Inter" pitchFamily="34" charset="-120"/>
               </a:rPr>
-              <a:t>NumPy argmax — &gt; 130.000 atualizações/iter</a:t>
+              <a:t>NumPy argmax — &gt; 130.000 atualizações/iter (p=12); p=11: greedy c/ atualização paralelizada</a:t>
             </a:r>
             <a:endParaRPr lang="en-US" sz="1425" dirty="0"/>
           </a:p>
@@ -19658,7 +19658,7 @@
                 <a:ea typeface="Inter" pitchFamily="34" charset="-122"/>
                 <a:cs typeface="Inter" pitchFamily="34" charset="-120"/>
               </a:rPr>
-              <a:t>NumPy argmax (p=12,11)</a:t>
+              <a:t>NumPy argmax (p=12) / Paralelo (p=11)</a:t>
             </a:r>
             <a:endParaRPr lang="en-US" sz="1125" dirty="0"/>
           </a:p>
@@ -23577,7 +23577,7 @@
                 <a:ea typeface="Inter" pitchFamily="34" charset="-122"/>
                 <a:cs typeface="Inter" pitchFamily="34" charset="-120"/>
               </a:rPr>
-              <a:t>NumPy argmax percorre 3,3M elementos/iter — O(N</a:t>
+              <a:t>NumPy argmax percorre 3,3M elementos/iter — O(N15) por iteração (p=12); p=11 paraleliza a atualização de count[]</a:t>
             </a:r>
             <a:r>
               <a:rPr lang="en-US" sz="1187" baseline="-40000" dirty="0">
@@ -23588,7 +23588,7 @@
                 <a:ea typeface="Inter" pitchFamily="34" charset="-122"/>
                 <a:cs typeface="Inter" pitchFamily="34" charset="-120"/>
               </a:rPr>
-              <a:t>15 </a:t>
+              <a:t/>
             </a:r>
             <a:r>
               <a:rPr lang="en-US" sz="1425" dirty="0">
@@ -23599,7 +23599,7 @@
                 <a:ea typeface="Inter" pitchFamily="34" charset="-122"/>
                 <a:cs typeface="Inter" pitchFamily="34" charset="-120"/>
               </a:rPr>
-              <a:t>) custo fixo por iteração (p=12,11)</a:t>
+              <a:t/>
             </a:r>
             <a:endParaRPr lang="en-US" sz="1425" dirty="0"/>
           </a:p>
@@ -25497,7 +25497,7 @@
                 <a:ea typeface="Inter" pitchFamily="34" charset="-122"/>
                 <a:cs typeface="Inter" pitchFamily="34" charset="-120"/>
               </a:rPr>
-              <a:t>Greedy argmax ★</a:t>
+              <a:t>Greedy argmax/paralelo ★</a:t>
             </a:r>
             <a:endParaRPr lang="en-US" sz="1425" dirty="0"/>
           </a:p>
@@ -28938,7 +28938,7 @@
                 <a:ea typeface="Inter" pitchFamily="34" charset="-122"/>
                 <a:cs typeface="Inter" pitchFamily="34" charset="-120"/>
               </a:rPr>
-              <a:t>LB-LP é assintoticamente apertado para instâncias uniformes C(n,k,t) quando n→∞. Verificado por amostragem (10.000 amostras/instância).</a:t>
+              <a:t>LB-LP é assintoticamente apertado para instâncias uniformes C(n,k,t) quando n→∞. Cobertura validada por auditoria exata dos arquivos .npy (audit_cobertura.py).</a:t>
             </a:r>
             <a:endParaRPr lang="en-US" sz="1200" dirty="0"/>
           </a:p>

</xml_diff>

<commit_message>
Add experimental benchmarks and column generation solver
- Introduced `benchmark.py` to run and export benchmarks for various set-cover solvers.
- Added a column generation demonstration solver (`column_generation_demo.py`).
- Generated detailed results for small and medium presets in CSV, JSON, and Markdown formats under `results/experiments`.
- Utilized multiple solvers: Greedy, Stochastic Greedy, GRASP, Lagrangian Relaxation, and Column Generation.
</commit_message>
<xml_diff>
--- a/docs/SCP_RA03.pptx
+++ b/docs/SCP_RA03.pptx
@@ -28927,7 +28927,7 @@
                 <a:ea typeface="Inter" pitchFamily="34" charset="-122"/>
                 <a:cs typeface="Inter" pitchFamily="34" charset="-120"/>
               </a:rPr>
-              <a:t>Rödl, 1985 — </a:t>
+              <a:t>Rödl, 1985 — LB-LP é assintoticamente apertado para instâncias uniformes C(n,k,t) quando n→∞. Auditoria exata concluída para p=11 e p=12; p=13 e p=14 pendentes por custo computacional (audit_cobertura.py disponível).</a:t>
             </a:r>
             <a:r>
               <a:rPr lang="en-US" sz="1350" dirty="0">
@@ -28938,7 +28938,7 @@
                 <a:ea typeface="Inter" pitchFamily="34" charset="-122"/>
                 <a:cs typeface="Inter" pitchFamily="34" charset="-120"/>
               </a:rPr>
-              <a:t>LB-LP é assintoticamente apertado para instâncias uniformes C(n,k,t) quando n→∞. Cobertura validada por auditoria exata dos arquivos .npy (audit_cobertura.py).</a:t>
+              <a:t/>
             </a:r>
             <a:endParaRPr lang="en-US" sz="1200" dirty="0"/>
           </a:p>

</xml_diff>

<commit_message>
Update `large-demo` preset for reproducibility and clarify its purpose in documentation
</commit_message>
<xml_diff>
--- a/docs/SCP_RA03.pptx
+++ b/docs/SCP_RA03.pptx
@@ -2906,28 +2906,6 @@
               </a:rPr>
               <a:t>Paralelização já implementada no Programa 5 (p=11, speedup ~3× em 4 núcleos). Melhorias futuras: expandir paralelismo, portar gargalos para C/Cython</a:t>
             </a:r>
-            <a:r>
-              <a:rPr lang="en-US" sz="1425" b="1" dirty="0">
-                <a:solidFill>
-                  <a:srgbClr val="FBBF24"/>
-                </a:solidFill>
-                <a:latin typeface="Inter" pitchFamily="34" charset="0"/>
-                <a:ea typeface="Inter" pitchFamily="34" charset="-122"/>
-                <a:cs typeface="Inter" pitchFamily="34" charset="-120"/>
-              </a:rPr>
-              <a:t/>
-            </a:r>
-            <a:r>
-              <a:rPr lang="en-US" sz="1425" dirty="0">
-                <a:solidFill>
-                  <a:srgbClr val="E2E8F0"/>
-                </a:solidFill>
-                <a:latin typeface="Inter" pitchFamily="34" charset="0"/>
-                <a:ea typeface="Inter" pitchFamily="34" charset="-122"/>
-                <a:cs typeface="Inter" pitchFamily="34" charset="-120"/>
-              </a:rPr>
-              <a:t/>
-            </a:r>
             <a:endParaRPr lang="en-US" sz="1425" dirty="0"/>
           </a:p>
         </p:txBody>
@@ -3646,6 +3624,53 @@
               <a:t>●</a:t>
             </a:r>
             <a:endParaRPr lang="en-US" sz="750" dirty="0"/>
+          </a:p>
+        </p:txBody>
+      </p:sp>
+      <p:sp>
+        <p:nvSpPr>
+          <p:cNvPr id="55" name="Shape 0">
+            <a:extLst>
+              <a:ext uri="{FF2B5EF4-FFF2-40B4-BE49-F238E27FC236}">
+                <a16:creationId xmlns:a16="http://schemas.microsoft.com/office/drawing/2014/main" id="{9F43B235-3203-0A1E-980A-1404C1FD38EB}"/>
+              </a:ext>
+            </a:extLst>
+          </p:cNvPr>
+          <p:cNvSpPr/>
+          <p:nvPr/>
+        </p:nvSpPr>
+        <p:spPr>
+          <a:xfrm>
+            <a:off x="0" y="0"/>
+            <a:ext cx="18288000" cy="10287000"/>
+          </a:xfrm>
+          <a:prstGeom prst="rect">
+            <a:avLst/>
+          </a:prstGeom>
+          <a:gradFill rotWithShape="1">
+            <a:gsLst>
+              <a:gs pos="0">
+                <a:srgbClr val="38BDF8">
+                  <a:alpha val="18000"/>
+                </a:srgbClr>
+              </a:gs>
+              <a:gs pos="42000">
+                <a:srgbClr val="38BDF8">
+                  <a:alpha val="0"/>
+                </a:srgbClr>
+              </a:gs>
+            </a:gsLst>
+            <a:path path="circle">
+              <a:fillToRect l="50000" t="100000" r="50000"/>
+            </a:path>
+          </a:gradFill>
+          <a:ln/>
+        </p:spPr>
+        <p:txBody>
+          <a:bodyPr/>
+          <a:lstStyle/>
+          <a:p>
+            <a:endParaRPr lang="pt-BR"/>
           </a:p>
         </p:txBody>
       </p:sp>
@@ -4329,28 +4354,6 @@
               </a:rPr>
               <a:t>Para cada p ∈ {14,13,12,11}, encontrar</a:t>
             </a:r>
-            <a:r>
-              <a:rPr lang="en-US" sz="1500" dirty="0">
-                <a:solidFill>
-                  <a:srgbClr val="38BDF8"/>
-                </a:solidFill>
-                <a:latin typeface="JetBrains Mono" pitchFamily="34" charset="0"/>
-                <a:ea typeface="JetBrains Mono" pitchFamily="34" charset="-122"/>
-                <a:cs typeface="JetBrains Mono" pitchFamily="34" charset="-120"/>
-              </a:rPr>
-              <a:t/>
-            </a:r>
-            <a:r>
-              <a:rPr lang="en-US" sz="1500" dirty="0">
-                <a:solidFill>
-                  <a:srgbClr val="E2E8F0"/>
-                </a:solidFill>
-                <a:latin typeface="JetBrains Mono" pitchFamily="34" charset="0"/>
-                <a:ea typeface="JetBrains Mono" pitchFamily="34" charset="-122"/>
-                <a:cs typeface="JetBrains Mono" pitchFamily="34" charset="-120"/>
-              </a:rPr>
-              <a:t/>
-            </a:r>
             <a:endParaRPr lang="en-US" sz="1500" dirty="0"/>
           </a:p>
         </p:txBody>
@@ -4394,39 +4397,6 @@
                 <a:cs typeface="JetBrains Mono" pitchFamily="34" charset="-120"/>
               </a:rPr>
               <a:t>um SB ⊆ S15 tal que: (objetivo: minimizar |SB|; implementação: greedy aproximativo)</a:t>
-            </a:r>
-            <a:r>
-              <a:rPr lang="en-US" sz="1500" b="1" dirty="0">
-                <a:solidFill>
-                  <a:srgbClr val="FBBF24"/>
-                </a:solidFill>
-                <a:latin typeface="JetBrains Mono" pitchFamily="34" charset="0"/>
-                <a:ea typeface="JetBrains Mono" pitchFamily="34" charset="-122"/>
-                <a:cs typeface="JetBrains Mono" pitchFamily="34" charset="-120"/>
-              </a:rPr>
-              <a:t/>
-            </a:r>
-            <a:r>
-              <a:rPr lang="en-US" sz="1250" b="1" baseline="-40000" dirty="0">
-                <a:solidFill>
-                  <a:srgbClr val="FBBF24"/>
-                </a:solidFill>
-                <a:latin typeface="JetBrains Mono" pitchFamily="34" charset="0"/>
-                <a:ea typeface="JetBrains Mono" pitchFamily="34" charset="-122"/>
-                <a:cs typeface="JetBrains Mono" pitchFamily="34" charset="-120"/>
-              </a:rPr>
-              <a:t/>
-            </a:r>
-            <a:r>
-              <a:rPr lang="en-US" sz="1500" dirty="0">
-                <a:solidFill>
-                  <a:srgbClr val="E2E8F0"/>
-                </a:solidFill>
-                <a:latin typeface="JetBrains Mono" pitchFamily="34" charset="0"/>
-                <a:ea typeface="JetBrains Mono" pitchFamily="34" charset="-122"/>
-                <a:cs typeface="JetBrains Mono" pitchFamily="34" charset="-120"/>
-              </a:rPr>
-              <a:t/>
             </a:r>
             <a:endParaRPr lang="en-US" sz="1500" dirty="0"/>
           </a:p>
@@ -22881,6 +22851,53 @@
       </p:grpSpPr>
       <p:sp>
         <p:nvSpPr>
+          <p:cNvPr id="85" name="Shape 0">
+            <a:extLst>
+              <a:ext uri="{FF2B5EF4-FFF2-40B4-BE49-F238E27FC236}">
+                <a16:creationId xmlns:a16="http://schemas.microsoft.com/office/drawing/2014/main" id="{5E7AFBEF-9BE8-1857-37C9-6324C0CF535E}"/>
+              </a:ext>
+            </a:extLst>
+          </p:cNvPr>
+          <p:cNvSpPr/>
+          <p:nvPr/>
+        </p:nvSpPr>
+        <p:spPr>
+          <a:xfrm>
+            <a:off x="0" y="0"/>
+            <a:ext cx="18288000" cy="10287000"/>
+          </a:xfrm>
+          <a:prstGeom prst="rect">
+            <a:avLst/>
+          </a:prstGeom>
+          <a:gradFill rotWithShape="1">
+            <a:gsLst>
+              <a:gs pos="0">
+                <a:srgbClr val="38BDF8">
+                  <a:alpha val="18000"/>
+                </a:srgbClr>
+              </a:gs>
+              <a:gs pos="42000">
+                <a:srgbClr val="38BDF8">
+                  <a:alpha val="0"/>
+                </a:srgbClr>
+              </a:gs>
+            </a:gsLst>
+            <a:path path="circle">
+              <a:fillToRect l="50000" t="100000" r="50000"/>
+            </a:path>
+          </a:gradFill>
+          <a:ln/>
+        </p:spPr>
+        <p:txBody>
+          <a:bodyPr/>
+          <a:lstStyle/>
+          <a:p>
+            <a:endParaRPr lang="pt-BR"/>
+          </a:p>
+        </p:txBody>
+      </p:sp>
+      <p:sp>
+        <p:nvSpPr>
           <p:cNvPr id="2" name="Text 0"/>
           <p:cNvSpPr/>
           <p:nvPr/>
@@ -23578,28 +23595,6 @@
                 <a:cs typeface="Inter" pitchFamily="34" charset="-120"/>
               </a:rPr>
               <a:t>NumPy argmax percorre 3,3M elementos/iter — O(N15) por iteração (p=12); p=11 paraleliza a atualização de count[]</a:t>
-            </a:r>
-            <a:r>
-              <a:rPr lang="en-US" sz="1187" baseline="-40000" dirty="0">
-                <a:solidFill>
-                  <a:srgbClr val="E2E8F0"/>
-                </a:solidFill>
-                <a:latin typeface="Inter" pitchFamily="34" charset="0"/>
-                <a:ea typeface="Inter" pitchFamily="34" charset="-122"/>
-                <a:cs typeface="Inter" pitchFamily="34" charset="-120"/>
-              </a:rPr>
-              <a:t/>
-            </a:r>
-            <a:r>
-              <a:rPr lang="en-US" sz="1425" dirty="0">
-                <a:solidFill>
-                  <a:srgbClr val="E2E8F0"/>
-                </a:solidFill>
-                <a:latin typeface="Inter" pitchFamily="34" charset="0"/>
-                <a:ea typeface="Inter" pitchFamily="34" charset="-122"/>
-                <a:cs typeface="Inter" pitchFamily="34" charset="-120"/>
-              </a:rPr>
-              <a:t/>
             </a:r>
             <a:endParaRPr lang="en-US" sz="1425" dirty="0"/>
           </a:p>
@@ -28929,17 +28924,6 @@
               </a:rPr>
               <a:t>Rödl, 1985 — LB-LP é assintoticamente apertado para instâncias uniformes C(n,k,t) quando n→∞. Auditoria exata concluída para p=11 e p=12; p=13 e p=14 pendentes por custo computacional (audit_cobertura.py disponível).</a:t>
             </a:r>
-            <a:r>
-              <a:rPr lang="en-US" sz="1350" dirty="0">
-                <a:solidFill>
-                  <a:srgbClr val="E2E8F0"/>
-                </a:solidFill>
-                <a:latin typeface="Inter" pitchFamily="34" charset="0"/>
-                <a:ea typeface="Inter" pitchFamily="34" charset="-122"/>
-                <a:cs typeface="Inter" pitchFamily="34" charset="-120"/>
-              </a:rPr>
-              <a:t/>
-            </a:r>
             <a:endParaRPr lang="en-US" sz="1200" dirty="0"/>
           </a:p>
         </p:txBody>
@@ -28974,7 +28958,11 @@
           <a:bodyPr/>
           <a:lstStyle/>
           <a:p>
-            <a:endParaRPr lang="pt-BR"/>
+            <a:endParaRPr lang="pt-BR">
+              <a:solidFill>
+                <a:schemeClr val="bg1"/>
+              </a:solidFill>
+            </a:endParaRPr>
           </a:p>
         </p:txBody>
       </p:sp>
@@ -29010,7 +28998,7 @@
             <a:r>
               <a:rPr lang="en-US" sz="1125" dirty="0">
                 <a:solidFill>
-                  <a:srgbClr val="475569"/>
+                  <a:schemeClr val="bg1"/>
                 </a:solidFill>
                 <a:latin typeface="JetBrains Mono" pitchFamily="34" charset="0"/>
                 <a:ea typeface="JetBrains Mono" pitchFamily="34" charset="-122"/>
@@ -29018,7 +29006,11 @@
               </a:rPr>
               <a:t>Intel Core i7-4770 @ 3,40 GHz 32 GB RAM · sem GPU · Windows 11</a:t>
             </a:r>
-            <a:endParaRPr lang="en-US" sz="1125" dirty="0"/>
+            <a:endParaRPr lang="en-US" sz="1125" dirty="0">
+              <a:solidFill>
+                <a:schemeClr val="bg1"/>
+              </a:solidFill>
+            </a:endParaRPr>
           </a:p>
         </p:txBody>
       </p:sp>

</xml_diff>